<commit_message>
MCG: naglowek z ramka na zdjecie Gosi
</commit_message>
<xml_diff>
--- a/MCG_skodun-3-kreacje_EDYTOWALNY.pptx
+++ b/MCG_skodun-3-kreacje_EDYTOWALNY.pptx
@@ -3176,17 +3176,429 @@
       </p:sp>
       <p:sp>
         <p:nvSpPr>
-          <p:cNvPr id="4" name="PLACEHOLDER-logo-wstaw-swoje"/>
+          <p:cNvPr id="4" name="RAMKA-ZDJECIE-GOSI-wrzuc-foto"/>
           <p:cNvSpPr/>
           <p:nvPr/>
         </p:nvSpPr>
         <p:spPr>
           <a:xfrm>
-            <a:off x="685800" y="609600"/>
-            <a:ext cx="1104900" cy="1104900"/>
+            <a:off x="685800" y="533400"/>
+            <a:ext cx="1371600" cy="1371600"/>
           </a:xfrm>
           <a:prstGeom prst="ellipse">
             <a:avLst/>
+          </a:prstGeom>
+          <a:solidFill>
+            <a:srgbClr val="3A3631"/>
+          </a:solidFill>
+          <a:ln w="50800">
+            <a:solidFill>
+              <a:srgbClr val="F58220"/>
+            </a:solidFill>
+          </a:ln>
+          <a:effectLst/>
+        </p:spPr>
+        <p:style>
+          <a:lnRef idx="1">
+            <a:schemeClr val="accent1"/>
+          </a:lnRef>
+          <a:fillRef idx="3">
+            <a:schemeClr val="accent1"/>
+          </a:fillRef>
+          <a:effectRef idx="2">
+            <a:schemeClr val="accent1"/>
+          </a:effectRef>
+          <a:fontRef idx="minor">
+            <a:schemeClr val="lt1"/>
+          </a:fontRef>
+        </p:style>
+        <p:txBody>
+          <a:bodyPr rtlCol="0" anchor="ctr"/>
+          <a:lstStyle/>
+          <a:p/>
+        </p:txBody>
+      </p:sp>
+      <p:sp>
+        <p:nvSpPr>
+          <p:cNvPr id="5" name="ramka-podpowiedz-usun"/>
+          <p:cNvSpPr txBox="1"/>
+          <p:nvPr/>
+        </p:nvSpPr>
+        <p:spPr>
+          <a:xfrm>
+            <a:off x="914400" y="1066800"/>
+            <a:ext cx="914400" cy="323850"/>
+          </a:xfrm>
+          <a:prstGeom prst="rect">
+            <a:avLst/>
+          </a:prstGeom>
+          <a:noFill/>
+        </p:spPr>
+        <p:txBody>
+          <a:bodyPr wrap="square" lIns="0" rIns="0" tIns="0" bIns="0" anchor="ctr">
+            <a:spAutoFit/>
+          </a:bodyPr>
+          <a:lstStyle/>
+          <a:p>
+            <a:pPr algn="ctr"/>
+            <a:r>
+              <a:rPr sz="1500" b="0" spc="300">
+                <a:solidFill>
+                  <a:srgbClr val="B8B2AA"/>
+                </a:solidFill>
+                <a:latin typeface="Open Sans"/>
+              </a:rPr>
+              <a:t>FOTO</a:t>
+            </a:r>
+          </a:p>
+        </p:txBody>
+      </p:sp>
+      <p:sp>
+        <p:nvSpPr>
+          <p:cNvPr id="6" name="kicker-imie"/>
+          <p:cNvSpPr txBox="1"/>
+          <p:nvPr/>
+        </p:nvSpPr>
+        <p:spPr>
+          <a:xfrm>
+            <a:off x="2324100" y="704850"/>
+            <a:ext cx="6667500" cy="342900"/>
+          </a:xfrm>
+          <a:prstGeom prst="rect">
+            <a:avLst/>
+          </a:prstGeom>
+          <a:noFill/>
+        </p:spPr>
+        <p:txBody>
+          <a:bodyPr wrap="square" lIns="0" rIns="0" tIns="0" bIns="0" anchor="ctr">
+            <a:spAutoFit/>
+          </a:bodyPr>
+          <a:lstStyle/>
+          <a:p>
+            <a:pPr algn="l"/>
+            <a:r>
+              <a:rPr sz="2025" b="1" spc="500">
+                <a:solidFill>
+                  <a:srgbClr val="F58220"/>
+                </a:solidFill>
+                <a:latin typeface="Montserrat"/>
+              </a:rPr>
+              <a:t>GOSIA</a:t>
+            </a:r>
+          </a:p>
+        </p:txBody>
+      </p:sp>
+      <p:sp>
+        <p:nvSpPr>
+          <p:cNvPr id="7" name="kicker-marka"/>
+          <p:cNvSpPr txBox="1"/>
+          <p:nvPr/>
+        </p:nvSpPr>
+        <p:spPr>
+          <a:xfrm>
+            <a:off x="2324100" y="1066800"/>
+            <a:ext cx="6667500" cy="304800"/>
+          </a:xfrm>
+          <a:prstGeom prst="rect">
+            <a:avLst/>
+          </a:prstGeom>
+          <a:noFill/>
+        </p:spPr>
+        <p:txBody>
+          <a:bodyPr wrap="square" lIns="0" rIns="0" tIns="0" bIns="0" anchor="ctr">
+            <a:spAutoFit/>
+          </a:bodyPr>
+          <a:lstStyle/>
+          <a:p>
+            <a:pPr algn="l"/>
+            <a:r>
+              <a:rPr sz="1725" b="1" spc="400">
+                <a:solidFill>
+                  <a:srgbClr val="FFFFFF"/>
+                </a:solidFill>
+                <a:latin typeface="Montserrat"/>
+              </a:rPr>
+              <a:t>MOUNTAIN CAR GARAGE</a:t>
+            </a:r>
+          </a:p>
+        </p:txBody>
+      </p:sp>
+      <p:sp>
+        <p:nvSpPr>
+          <p:cNvPr id="8" name="kicker-lokalizacja"/>
+          <p:cNvSpPr txBox="1"/>
+          <p:nvPr/>
+        </p:nvSpPr>
+        <p:spPr>
+          <a:xfrm>
+            <a:off x="2324100" y="1390650"/>
+            <a:ext cx="6667500" cy="266700"/>
+          </a:xfrm>
+          <a:prstGeom prst="rect">
+            <a:avLst/>
+          </a:prstGeom>
+          <a:noFill/>
+        </p:spPr>
+        <p:txBody>
+          <a:bodyPr wrap="square" lIns="0" rIns="0" tIns="0" bIns="0" anchor="ctr">
+            <a:spAutoFit/>
+          </a:bodyPr>
+          <a:lstStyle/>
+          <a:p>
+            <a:pPr algn="l"/>
+            <a:r>
+              <a:rPr sz="1425" b="0" spc="300">
+                <a:solidFill>
+                  <a:srgbClr val="D4AF37"/>
+                </a:solidFill>
+                <a:latin typeface="Open Sans"/>
+              </a:rPr>
+              <a:t>NJARÐVÍK · REYKJANESBÆR</a:t>
+            </a:r>
+          </a:p>
+        </p:txBody>
+      </p:sp>
+      <p:sp>
+        <p:nvSpPr>
+          <p:cNvPr id="9" name="pasek-stopka"/>
+          <p:cNvSpPr/>
+          <p:nvPr/>
+        </p:nvSpPr>
+        <p:spPr>
+          <a:xfrm>
+            <a:off x="0" y="11430000"/>
+            <a:ext cx="10287000" cy="1428750"/>
+          </a:xfrm>
+          <a:prstGeom prst="rect">
+            <a:avLst/>
+          </a:prstGeom>
+          <a:solidFill>
+            <a:srgbClr val="F58220"/>
+          </a:solidFill>
+          <a:ln>
+            <a:noFill/>
+          </a:ln>
+          <a:effectLst/>
+        </p:spPr>
+        <p:style>
+          <a:lnRef idx="1">
+            <a:schemeClr val="accent1"/>
+          </a:lnRef>
+          <a:fillRef idx="3">
+            <a:schemeClr val="accent1"/>
+          </a:fillRef>
+          <a:effectRef idx="2">
+            <a:schemeClr val="accent1"/>
+          </a:effectRef>
+          <a:fontRef idx="minor">
+            <a:schemeClr val="lt1"/>
+          </a:fontRef>
+        </p:style>
+        <p:txBody>
+          <a:bodyPr rtlCol="0" anchor="ctr"/>
+          <a:lstStyle/>
+          <a:p/>
+        </p:txBody>
+      </p:sp>
+      <p:sp>
+        <p:nvSpPr>
+          <p:cNvPr id="10" name="p1-naglowek"/>
+          <p:cNvSpPr txBox="1"/>
+          <p:nvPr/>
+        </p:nvSpPr>
+        <p:spPr>
+          <a:xfrm>
+            <a:off x="685800" y="2305050"/>
+            <a:ext cx="8915400" cy="3143250"/>
+          </a:xfrm>
+          <a:prstGeom prst="rect">
+            <a:avLst/>
+          </a:prstGeom>
+          <a:noFill/>
+        </p:spPr>
+        <p:txBody>
+          <a:bodyPr wrap="square" lIns="0" rIns="0" tIns="0" bIns="0" anchor="t">
+            <a:spAutoFit/>
+          </a:bodyPr>
+          <a:lstStyle/>
+          <a:p>
+            <a:pPr algn="l">
+              <a:lnSpc>
+                <a:spcPct val="100000"/>
+              </a:lnSpc>
+            </a:pPr>
+            <a:r>
+              <a:rPr sz="6000" b="1">
+                <a:solidFill>
+                  <a:srgbClr val="FFFFFF"/>
+                </a:solidFill>
+                <a:latin typeface="Montserrat"/>
+              </a:rPr>
+              <a:t>NIE ZOSTAWIAJ</a:t>
+            </a:r>
+          </a:p>
+          <a:p>
+            <a:pPr algn="l">
+              <a:lnSpc>
+                <a:spcPct val="100000"/>
+              </a:lnSpc>
+            </a:pPr>
+            <a:r>
+              <a:rPr sz="6000" b="1">
+                <a:solidFill>
+                  <a:srgbClr val="FFFFFF"/>
+                </a:solidFill>
+                <a:latin typeface="Montserrat"/>
+              </a:rPr>
+              <a:t>NA OSTATNI</a:t>
+            </a:r>
+          </a:p>
+          <a:p>
+            <a:pPr algn="l">
+              <a:lnSpc>
+                <a:spcPct val="100000"/>
+              </a:lnSpc>
+            </a:pPr>
+            <a:r>
+              <a:rPr sz="6000" b="1">
+                <a:solidFill>
+                  <a:srgbClr val="F58220"/>
+                </a:solidFill>
+                <a:latin typeface="Montserrat"/>
+              </a:rPr>
+              <a:t>TYDZIEŃ.</a:t>
+            </a:r>
+          </a:p>
+        </p:txBody>
+      </p:sp>
+      <p:sp>
+        <p:nvSpPr>
+          <p:cNvPr id="11" name="p1-kreska"/>
+          <p:cNvSpPr/>
+          <p:nvPr/>
+        </p:nvSpPr>
+        <p:spPr>
+          <a:xfrm>
+            <a:off x="685800" y="5715000"/>
+            <a:ext cx="1428750" cy="57150"/>
+          </a:xfrm>
+          <a:prstGeom prst="rect">
+            <a:avLst/>
+          </a:prstGeom>
+          <a:solidFill>
+            <a:srgbClr val="D4AF37"/>
+          </a:solidFill>
+          <a:ln>
+            <a:noFill/>
+          </a:ln>
+          <a:effectLst/>
+        </p:spPr>
+        <p:style>
+          <a:lnRef idx="1">
+            <a:schemeClr val="accent1"/>
+          </a:lnRef>
+          <a:fillRef idx="3">
+            <a:schemeClr val="accent1"/>
+          </a:fillRef>
+          <a:effectRef idx="2">
+            <a:schemeClr val="accent1"/>
+          </a:effectRef>
+          <a:fontRef idx="minor">
+            <a:schemeClr val="lt1"/>
+          </a:fontRef>
+        </p:style>
+        <p:txBody>
+          <a:bodyPr rtlCol="0" anchor="ctr"/>
+          <a:lstStyle/>
+          <a:p/>
+        </p:txBody>
+      </p:sp>
+      <p:sp>
+        <p:nvSpPr>
+          <p:cNvPr id="12" name="p1-tresc"/>
+          <p:cNvSpPr txBox="1"/>
+          <p:nvPr/>
+        </p:nvSpPr>
+        <p:spPr>
+          <a:xfrm>
+            <a:off x="685800" y="6096000"/>
+            <a:ext cx="8915400" cy="1809750"/>
+          </a:xfrm>
+          <a:prstGeom prst="rect">
+            <a:avLst/>
+          </a:prstGeom>
+          <a:noFill/>
+        </p:spPr>
+        <p:txBody>
+          <a:bodyPr wrap="square" lIns="0" rIns="0" tIns="0" bIns="0" anchor="t">
+            <a:spAutoFit/>
+          </a:bodyPr>
+          <a:lstStyle/>
+          <a:p>
+            <a:pPr algn="l">
+              <a:lnSpc>
+                <a:spcPct val="135000"/>
+              </a:lnSpc>
+            </a:pPr>
+            <a:r>
+              <a:rPr sz="2400" b="0">
+                <a:solidFill>
+                  <a:srgbClr val="B8B2AA"/>
+                </a:solidFill>
+                <a:latin typeface="Open Sans"/>
+              </a:rPr>
+              <a:t>Auto nie przeszło skoðun. Naprawa drobna —</a:t>
+            </a:r>
+          </a:p>
+          <a:p>
+            <a:pPr algn="l">
+              <a:lnSpc>
+                <a:spcPct val="135000"/>
+              </a:lnSpc>
+            </a:pPr>
+            <a:r>
+              <a:rPr sz="2400" b="0">
+                <a:solidFill>
+                  <a:srgbClr val="B8B2AA"/>
+                </a:solidFill>
+                <a:latin typeface="Open Sans"/>
+              </a:rPr>
+              <a:t>ale tej części nie ma na Islandii i trzeba ją</a:t>
+            </a:r>
+          </a:p>
+          <a:p>
+            <a:pPr algn="l">
+              <a:lnSpc>
+                <a:spcPct val="135000"/>
+              </a:lnSpc>
+            </a:pPr>
+            <a:r>
+              <a:rPr sz="2400" b="0">
+                <a:solidFill>
+                  <a:srgbClr val="B8B2AA"/>
+                </a:solidFill>
+                <a:latin typeface="Open Sans"/>
+              </a:rPr>
+              <a:t>zamawiać. A termin leci dalej.</a:t>
+            </a:r>
+          </a:p>
+        </p:txBody>
+      </p:sp>
+      <p:sp>
+        <p:nvSpPr>
+          <p:cNvPr id="13" name="karta-kwota-obwodka"/>
+          <p:cNvSpPr/>
+          <p:nvPr/>
+        </p:nvSpPr>
+        <p:spPr>
+          <a:xfrm>
+            <a:off x="685800" y="8305800"/>
+            <a:ext cx="8915400" cy="2057400"/>
+          </a:xfrm>
+          <a:prstGeom prst="roundRect">
+            <a:avLst>
+              <a:gd name="adj" fmla="val 10000"/>
+            </a:avLst>
           </a:prstGeom>
           <a:noFill/>
           <a:ln w="38100">
@@ -3218,161 +3630,14 @@
       </p:sp>
       <p:sp>
         <p:nvSpPr>
-          <p:cNvPr id="5" name="logo-placeholder-napis"/>
+          <p:cNvPr id="14" name="karta-kwota-liczba"/>
           <p:cNvSpPr txBox="1"/>
           <p:nvPr/>
         </p:nvSpPr>
         <p:spPr>
           <a:xfrm>
-            <a:off x="914400" y="990600"/>
-            <a:ext cx="685800" cy="342900"/>
-          </a:xfrm>
-          <a:prstGeom prst="rect">
-            <a:avLst/>
-          </a:prstGeom>
-          <a:noFill/>
-        </p:spPr>
-        <p:txBody>
-          <a:bodyPr wrap="square" lIns="0" rIns="0" tIns="0" bIns="0" anchor="ctr">
-            <a:spAutoFit/>
-          </a:bodyPr>
-          <a:lstStyle/>
-          <a:p>
-            <a:pPr algn="ctr"/>
-            <a:r>
-              <a:rPr sz="1950" b="1" spc="200">
-                <a:solidFill>
-                  <a:srgbClr val="D4AF37"/>
-                </a:solidFill>
-                <a:latin typeface="Montserrat"/>
-              </a:rPr>
-              <a:t>MCG</a:t>
-            </a:r>
-          </a:p>
-        </p:txBody>
-      </p:sp>
-      <p:sp>
-        <p:nvSpPr>
-          <p:cNvPr id="6" name="kicker-marka"/>
-          <p:cNvSpPr txBox="1"/>
-          <p:nvPr/>
-        </p:nvSpPr>
-        <p:spPr>
-          <a:xfrm>
-            <a:off x="2019300" y="819150"/>
-            <a:ext cx="6667500" cy="323850"/>
-          </a:xfrm>
-          <a:prstGeom prst="rect">
-            <a:avLst/>
-          </a:prstGeom>
-          <a:noFill/>
-        </p:spPr>
-        <p:txBody>
-          <a:bodyPr wrap="square" lIns="0" rIns="0" tIns="0" bIns="0" anchor="ctr">
-            <a:spAutoFit/>
-          </a:bodyPr>
-          <a:lstStyle/>
-          <a:p>
-            <a:pPr algn="l"/>
-            <a:r>
-              <a:rPr sz="1875" b="1" spc="450">
-                <a:solidFill>
-                  <a:srgbClr val="FFFFFF"/>
-                </a:solidFill>
-                <a:latin typeface="Montserrat"/>
-              </a:rPr>
-              <a:t>MOUNTAIN CAR GARAGE</a:t>
-            </a:r>
-          </a:p>
-        </p:txBody>
-      </p:sp>
-      <p:sp>
-        <p:nvSpPr>
-          <p:cNvPr id="7" name="kicker-lokalizacja"/>
-          <p:cNvSpPr txBox="1"/>
-          <p:nvPr/>
-        </p:nvSpPr>
-        <p:spPr>
-          <a:xfrm>
-            <a:off x="2019300" y="1181100"/>
-            <a:ext cx="6667500" cy="285750"/>
-          </a:xfrm>
-          <a:prstGeom prst="rect">
-            <a:avLst/>
-          </a:prstGeom>
-          <a:noFill/>
-        </p:spPr>
-        <p:txBody>
-          <a:bodyPr wrap="square" lIns="0" rIns="0" tIns="0" bIns="0" anchor="ctr">
-            <a:spAutoFit/>
-          </a:bodyPr>
-          <a:lstStyle/>
-          <a:p>
-            <a:pPr algn="l"/>
-            <a:r>
-              <a:rPr sz="1575" b="0" spc="300">
-                <a:solidFill>
-                  <a:srgbClr val="D4AF37"/>
-                </a:solidFill>
-                <a:latin typeface="Open Sans"/>
-              </a:rPr>
-              <a:t>NJARÐVÍK · REYKJANESBÆR</a:t>
-            </a:r>
-          </a:p>
-        </p:txBody>
-      </p:sp>
-      <p:sp>
-        <p:nvSpPr>
-          <p:cNvPr id="8" name="pasek-stopka"/>
-          <p:cNvSpPr/>
-          <p:nvPr/>
-        </p:nvSpPr>
-        <p:spPr>
-          <a:xfrm>
-            <a:off x="0" y="11430000"/>
-            <a:ext cx="10287000" cy="1428750"/>
-          </a:xfrm>
-          <a:prstGeom prst="rect">
-            <a:avLst/>
-          </a:prstGeom>
-          <a:solidFill>
-            <a:srgbClr val="F58220"/>
-          </a:solidFill>
-          <a:ln>
-            <a:noFill/>
-          </a:ln>
-          <a:effectLst/>
-        </p:spPr>
-        <p:style>
-          <a:lnRef idx="1">
-            <a:schemeClr val="accent1"/>
-          </a:lnRef>
-          <a:fillRef idx="3">
-            <a:schemeClr val="accent1"/>
-          </a:fillRef>
-          <a:effectRef idx="2">
-            <a:schemeClr val="accent1"/>
-          </a:effectRef>
-          <a:fontRef idx="minor">
-            <a:schemeClr val="lt1"/>
-          </a:fontRef>
-        </p:style>
-        <p:txBody>
-          <a:bodyPr rtlCol="0" anchor="ctr"/>
-          <a:lstStyle/>
-          <a:p/>
-        </p:txBody>
-      </p:sp>
-      <p:sp>
-        <p:nvSpPr>
-          <p:cNvPr id="9" name="p1-naglowek"/>
-          <p:cNvSpPr txBox="1"/>
-          <p:nvPr/>
-        </p:nvSpPr>
-        <p:spPr>
-          <a:xfrm>
-            <a:off x="685800" y="2305050"/>
-            <a:ext cx="8915400" cy="3143250"/>
+            <a:off x="1028700" y="8515350"/>
+            <a:ext cx="6667500" cy="914400"/>
           </a:xfrm>
           <a:prstGeom prst="rect">
             <a:avLst/>
@@ -3385,234 +3650,6 @@
           </a:bodyPr>
           <a:lstStyle/>
           <a:p>
-            <a:pPr algn="l">
-              <a:lnSpc>
-                <a:spcPct val="100000"/>
-              </a:lnSpc>
-            </a:pPr>
-            <a:r>
-              <a:rPr sz="6000" b="1">
-                <a:solidFill>
-                  <a:srgbClr val="FFFFFF"/>
-                </a:solidFill>
-                <a:latin typeface="Montserrat"/>
-              </a:rPr>
-              <a:t>NIE ZOSTAWIAJ</a:t>
-            </a:r>
-          </a:p>
-          <a:p>
-            <a:pPr algn="l">
-              <a:lnSpc>
-                <a:spcPct val="100000"/>
-              </a:lnSpc>
-            </a:pPr>
-            <a:r>
-              <a:rPr sz="6000" b="1">
-                <a:solidFill>
-                  <a:srgbClr val="FFFFFF"/>
-                </a:solidFill>
-                <a:latin typeface="Montserrat"/>
-              </a:rPr>
-              <a:t>NA OSTATNI</a:t>
-            </a:r>
-          </a:p>
-          <a:p>
-            <a:pPr algn="l">
-              <a:lnSpc>
-                <a:spcPct val="100000"/>
-              </a:lnSpc>
-            </a:pPr>
-            <a:r>
-              <a:rPr sz="6000" b="1">
-                <a:solidFill>
-                  <a:srgbClr val="F58220"/>
-                </a:solidFill>
-                <a:latin typeface="Montserrat"/>
-              </a:rPr>
-              <a:t>TYDZIEŃ.</a:t>
-            </a:r>
-          </a:p>
-        </p:txBody>
-      </p:sp>
-      <p:sp>
-        <p:nvSpPr>
-          <p:cNvPr id="10" name="p1-kreska"/>
-          <p:cNvSpPr/>
-          <p:nvPr/>
-        </p:nvSpPr>
-        <p:spPr>
-          <a:xfrm>
-            <a:off x="685800" y="5715000"/>
-            <a:ext cx="1428750" cy="57150"/>
-          </a:xfrm>
-          <a:prstGeom prst="rect">
-            <a:avLst/>
-          </a:prstGeom>
-          <a:solidFill>
-            <a:srgbClr val="D4AF37"/>
-          </a:solidFill>
-          <a:ln>
-            <a:noFill/>
-          </a:ln>
-          <a:effectLst/>
-        </p:spPr>
-        <p:style>
-          <a:lnRef idx="1">
-            <a:schemeClr val="accent1"/>
-          </a:lnRef>
-          <a:fillRef idx="3">
-            <a:schemeClr val="accent1"/>
-          </a:fillRef>
-          <a:effectRef idx="2">
-            <a:schemeClr val="accent1"/>
-          </a:effectRef>
-          <a:fontRef idx="minor">
-            <a:schemeClr val="lt1"/>
-          </a:fontRef>
-        </p:style>
-        <p:txBody>
-          <a:bodyPr rtlCol="0" anchor="ctr"/>
-          <a:lstStyle/>
-          <a:p/>
-        </p:txBody>
-      </p:sp>
-      <p:sp>
-        <p:nvSpPr>
-          <p:cNvPr id="11" name="p1-tresc"/>
-          <p:cNvSpPr txBox="1"/>
-          <p:nvPr/>
-        </p:nvSpPr>
-        <p:spPr>
-          <a:xfrm>
-            <a:off x="685800" y="6096000"/>
-            <a:ext cx="8915400" cy="1809750"/>
-          </a:xfrm>
-          <a:prstGeom prst="rect">
-            <a:avLst/>
-          </a:prstGeom>
-          <a:noFill/>
-        </p:spPr>
-        <p:txBody>
-          <a:bodyPr wrap="square" lIns="0" rIns="0" tIns="0" bIns="0" anchor="t">
-            <a:spAutoFit/>
-          </a:bodyPr>
-          <a:lstStyle/>
-          <a:p>
-            <a:pPr algn="l">
-              <a:lnSpc>
-                <a:spcPct val="135000"/>
-              </a:lnSpc>
-            </a:pPr>
-            <a:r>
-              <a:rPr sz="2400" b="0">
-                <a:solidFill>
-                  <a:srgbClr val="B8B2AA"/>
-                </a:solidFill>
-                <a:latin typeface="Open Sans"/>
-              </a:rPr>
-              <a:t>Auto nie przeszło skoðun. Naprawa drobna —</a:t>
-            </a:r>
-          </a:p>
-          <a:p>
-            <a:pPr algn="l">
-              <a:lnSpc>
-                <a:spcPct val="135000"/>
-              </a:lnSpc>
-            </a:pPr>
-            <a:r>
-              <a:rPr sz="2400" b="0">
-                <a:solidFill>
-                  <a:srgbClr val="B8B2AA"/>
-                </a:solidFill>
-                <a:latin typeface="Open Sans"/>
-              </a:rPr>
-              <a:t>ale tej części nie ma na Islandii i trzeba ją</a:t>
-            </a:r>
-          </a:p>
-          <a:p>
-            <a:pPr algn="l">
-              <a:lnSpc>
-                <a:spcPct val="135000"/>
-              </a:lnSpc>
-            </a:pPr>
-            <a:r>
-              <a:rPr sz="2400" b="0">
-                <a:solidFill>
-                  <a:srgbClr val="B8B2AA"/>
-                </a:solidFill>
-                <a:latin typeface="Open Sans"/>
-              </a:rPr>
-              <a:t>zamawiać. A termin leci dalej.</a:t>
-            </a:r>
-          </a:p>
-        </p:txBody>
-      </p:sp>
-      <p:sp>
-        <p:nvSpPr>
-          <p:cNvPr id="12" name="karta-kwota-obwodka"/>
-          <p:cNvSpPr/>
-          <p:nvPr/>
-        </p:nvSpPr>
-        <p:spPr>
-          <a:xfrm>
-            <a:off x="685800" y="8305800"/>
-            <a:ext cx="8915400" cy="2057400"/>
-          </a:xfrm>
-          <a:prstGeom prst="roundRect">
-            <a:avLst>
-              <a:gd name="adj" fmla="val 10000"/>
-            </a:avLst>
-          </a:prstGeom>
-          <a:noFill/>
-          <a:ln w="38100">
-            <a:solidFill>
-              <a:srgbClr val="D4AF37"/>
-            </a:solidFill>
-          </a:ln>
-          <a:effectLst/>
-        </p:spPr>
-        <p:style>
-          <a:lnRef idx="1">
-            <a:schemeClr val="accent1"/>
-          </a:lnRef>
-          <a:fillRef idx="3">
-            <a:schemeClr val="accent1"/>
-          </a:fillRef>
-          <a:effectRef idx="2">
-            <a:schemeClr val="accent1"/>
-          </a:effectRef>
-          <a:fontRef idx="minor">
-            <a:schemeClr val="lt1"/>
-          </a:fontRef>
-        </p:style>
-        <p:txBody>
-          <a:bodyPr rtlCol="0" anchor="ctr"/>
-          <a:lstStyle/>
-          <a:p/>
-        </p:txBody>
-      </p:sp>
-      <p:sp>
-        <p:nvSpPr>
-          <p:cNvPr id="13" name="karta-kwota-liczba"/>
-          <p:cNvSpPr txBox="1"/>
-          <p:nvPr/>
-        </p:nvSpPr>
-        <p:spPr>
-          <a:xfrm>
-            <a:off x="1028700" y="8515350"/>
-            <a:ext cx="6667500" cy="914400"/>
-          </a:xfrm>
-          <a:prstGeom prst="rect">
-            <a:avLst/>
-          </a:prstGeom>
-          <a:noFill/>
-        </p:spPr>
-        <p:txBody>
-          <a:bodyPr wrap="square" lIns="0" rIns="0" tIns="0" bIns="0" anchor="t">
-            <a:spAutoFit/>
-          </a:bodyPr>
-          <a:lstStyle/>
-          <a:p>
             <a:pPr algn="l"/>
             <a:r>
               <a:rPr sz="6600" b="1">
@@ -3628,7 +3665,7 @@
       </p:sp>
       <p:sp>
         <p:nvSpPr>
-          <p:cNvPr id="14" name="karta-kwota-opis"/>
+          <p:cNvPr id="15" name="karta-kwota-opis"/>
           <p:cNvSpPr txBox="1"/>
           <p:nvPr/>
         </p:nvSpPr>
@@ -3683,7 +3720,7 @@
       </p:sp>
       <p:sp>
         <p:nvSpPr>
-          <p:cNvPr id="15" name="stopka-linia-1"/>
+          <p:cNvPr id="16" name="stopka-linia-1"/>
           <p:cNvSpPr txBox="1"/>
           <p:nvPr/>
         </p:nvSpPr>
@@ -3718,7 +3755,7 @@
       </p:sp>
       <p:sp>
         <p:nvSpPr>
-          <p:cNvPr id="16" name="stopka-linia-2"/>
+          <p:cNvPr id="17" name="stopka-linia-2"/>
           <p:cNvSpPr txBox="1"/>
           <p:nvPr/>
         </p:nvSpPr>
@@ -3855,22 +3892,24 @@
       </p:sp>
       <p:sp>
         <p:nvSpPr>
-          <p:cNvPr id="4" name="PLACEHOLDER-logo-wstaw-swoje"/>
+          <p:cNvPr id="4" name="RAMKA-ZDJECIE-GOSI-wrzuc-foto"/>
           <p:cNvSpPr/>
           <p:nvPr/>
         </p:nvSpPr>
         <p:spPr>
           <a:xfrm>
-            <a:off x="685800" y="609600"/>
-            <a:ext cx="1104900" cy="1104900"/>
+            <a:off x="685800" y="533400"/>
+            <a:ext cx="1371600" cy="1371600"/>
           </a:xfrm>
           <a:prstGeom prst="ellipse">
             <a:avLst/>
           </a:prstGeom>
-          <a:noFill/>
-          <a:ln w="38100">
+          <a:solidFill>
+            <a:srgbClr val="3A3631"/>
+          </a:solidFill>
+          <a:ln w="50800">
             <a:solidFill>
-              <a:srgbClr val="D4AF37"/>
+              <a:srgbClr val="F58220"/>
             </a:solidFill>
           </a:ln>
           <a:effectLst/>
@@ -3897,14 +3936,14 @@
       </p:sp>
       <p:sp>
         <p:nvSpPr>
-          <p:cNvPr id="5" name="logo-placeholder-napis"/>
+          <p:cNvPr id="5" name="ramka-podpowiedz-usun"/>
           <p:cNvSpPr txBox="1"/>
           <p:nvPr/>
         </p:nvSpPr>
         <p:spPr>
           <a:xfrm>
-            <a:off x="914400" y="990600"/>
-            <a:ext cx="685800" cy="342900"/>
+            <a:off x="914400" y="1066800"/>
+            <a:ext cx="914400" cy="323850"/>
           </a:xfrm>
           <a:prstGeom prst="rect">
             <a:avLst/>
@@ -3919,27 +3958,27 @@
           <a:p>
             <a:pPr algn="ctr"/>
             <a:r>
-              <a:rPr sz="1950" b="1" spc="200">
-                <a:solidFill>
-                  <a:srgbClr val="D4AF37"/>
-                </a:solidFill>
-                <a:latin typeface="Montserrat"/>
+              <a:rPr sz="1500" b="0" spc="300">
+                <a:solidFill>
+                  <a:srgbClr val="B8B2AA"/>
+                </a:solidFill>
+                <a:latin typeface="Open Sans"/>
               </a:rPr>
-              <a:t>MCG</a:t>
-            </a:r>
-          </a:p>
-        </p:txBody>
-      </p:sp>
-      <p:sp>
-        <p:nvSpPr>
-          <p:cNvPr id="6" name="kicker-marka"/>
+              <a:t>FOTO</a:t>
+            </a:r>
+          </a:p>
+        </p:txBody>
+      </p:sp>
+      <p:sp>
+        <p:nvSpPr>
+          <p:cNvPr id="6" name="kicker-imie"/>
           <p:cNvSpPr txBox="1"/>
           <p:nvPr/>
         </p:nvSpPr>
         <p:spPr>
           <a:xfrm>
-            <a:off x="2019300" y="819150"/>
-            <a:ext cx="6667500" cy="323850"/>
+            <a:off x="2324100" y="704850"/>
+            <a:ext cx="6667500" cy="342900"/>
           </a:xfrm>
           <a:prstGeom prst="rect">
             <a:avLst/>
@@ -3954,7 +3993,42 @@
           <a:p>
             <a:pPr algn="l"/>
             <a:r>
-              <a:rPr sz="1875" b="1" spc="450">
+              <a:rPr sz="2025" b="1" spc="500">
+                <a:solidFill>
+                  <a:srgbClr val="F58220"/>
+                </a:solidFill>
+                <a:latin typeface="Montserrat"/>
+              </a:rPr>
+              <a:t>GOSIA</a:t>
+            </a:r>
+          </a:p>
+        </p:txBody>
+      </p:sp>
+      <p:sp>
+        <p:nvSpPr>
+          <p:cNvPr id="7" name="kicker-marka"/>
+          <p:cNvSpPr txBox="1"/>
+          <p:nvPr/>
+        </p:nvSpPr>
+        <p:spPr>
+          <a:xfrm>
+            <a:off x="2324100" y="1066800"/>
+            <a:ext cx="6667500" cy="304800"/>
+          </a:xfrm>
+          <a:prstGeom prst="rect">
+            <a:avLst/>
+          </a:prstGeom>
+          <a:noFill/>
+        </p:spPr>
+        <p:txBody>
+          <a:bodyPr wrap="square" lIns="0" rIns="0" tIns="0" bIns="0" anchor="ctr">
+            <a:spAutoFit/>
+          </a:bodyPr>
+          <a:lstStyle/>
+          <a:p>
+            <a:pPr algn="l"/>
+            <a:r>
+              <a:rPr sz="1725" b="1" spc="400">
                 <a:solidFill>
                   <a:srgbClr val="FFFFFF"/>
                 </a:solidFill>
@@ -3967,14 +4041,14 @@
       </p:sp>
       <p:sp>
         <p:nvSpPr>
-          <p:cNvPr id="7" name="kicker-lokalizacja"/>
+          <p:cNvPr id="8" name="kicker-lokalizacja"/>
           <p:cNvSpPr txBox="1"/>
           <p:nvPr/>
         </p:nvSpPr>
         <p:spPr>
           <a:xfrm>
-            <a:off x="2019300" y="1181100"/>
-            <a:ext cx="6667500" cy="285750"/>
+            <a:off x="2324100" y="1390650"/>
+            <a:ext cx="6667500" cy="266700"/>
           </a:xfrm>
           <a:prstGeom prst="rect">
             <a:avLst/>
@@ -3989,7 +4063,7 @@
           <a:p>
             <a:pPr algn="l"/>
             <a:r>
-              <a:rPr sz="1575" b="0" spc="300">
+              <a:rPr sz="1425" b="0" spc="300">
                 <a:solidFill>
                   <a:srgbClr val="D4AF37"/>
                 </a:solidFill>
@@ -4002,7 +4076,7 @@
       </p:sp>
       <p:sp>
         <p:nvSpPr>
-          <p:cNvPr id="8" name="pasek-stopka"/>
+          <p:cNvPr id="9" name="pasek-stopka"/>
           <p:cNvSpPr/>
           <p:nvPr/>
         </p:nvSpPr>
@@ -4044,7 +4118,7 @@
       </p:sp>
       <p:sp>
         <p:nvSpPr>
-          <p:cNvPr id="9" name="p2-naglowek"/>
+          <p:cNvPr id="10" name="p2-naglowek"/>
           <p:cNvSpPr txBox="1"/>
           <p:nvPr/>
         </p:nvSpPr>
@@ -4099,7 +4173,7 @@
       </p:sp>
       <p:sp>
         <p:nvSpPr>
-          <p:cNvPr id="10" name="p2-podtytul"/>
+          <p:cNvPr id="11" name="p2-podtytul"/>
           <p:cNvSpPr txBox="1"/>
           <p:nvPr/>
         </p:nvSpPr>
@@ -4134,7 +4208,7 @@
       </p:sp>
       <p:sp>
         <p:nvSpPr>
-          <p:cNvPr id="11" name="p2-kreska"/>
+          <p:cNvPr id="12" name="p2-kreska"/>
           <p:cNvSpPr/>
           <p:nvPr/>
         </p:nvSpPr>
@@ -4176,7 +4250,7 @@
       </p:sp>
       <p:sp>
         <p:nvSpPr>
-          <p:cNvPr id="12" name="p2-linia-1"/>
+          <p:cNvPr id="13" name="p2-linia-1"/>
           <p:cNvSpPr/>
           <p:nvPr/>
         </p:nvSpPr>
@@ -4218,7 +4292,7 @@
       </p:sp>
       <p:sp>
         <p:nvSpPr>
-          <p:cNvPr id="13" name="p2-pozycja-1"/>
+          <p:cNvPr id="14" name="p2-pozycja-1"/>
           <p:cNvSpPr txBox="1"/>
           <p:nvPr/>
         </p:nvSpPr>
@@ -4253,7 +4327,7 @@
       </p:sp>
       <p:sp>
         <p:nvSpPr>
-          <p:cNvPr id="14" name="p2-cena-1"/>
+          <p:cNvPr id="15" name="p2-cena-1"/>
           <p:cNvSpPr txBox="1"/>
           <p:nvPr/>
         </p:nvSpPr>
@@ -4288,7 +4362,7 @@
       </p:sp>
       <p:sp>
         <p:nvSpPr>
-          <p:cNvPr id="15" name="p2-linia-2"/>
+          <p:cNvPr id="16" name="p2-linia-2"/>
           <p:cNvSpPr/>
           <p:nvPr/>
         </p:nvSpPr>
@@ -4330,7 +4404,7 @@
       </p:sp>
       <p:sp>
         <p:nvSpPr>
-          <p:cNvPr id="16" name="p2-pozycja-2"/>
+          <p:cNvPr id="17" name="p2-pozycja-2"/>
           <p:cNvSpPr txBox="1"/>
           <p:nvPr/>
         </p:nvSpPr>
@@ -4365,7 +4439,7 @@
       </p:sp>
       <p:sp>
         <p:nvSpPr>
-          <p:cNvPr id="17" name="p2-cena-2"/>
+          <p:cNvPr id="18" name="p2-cena-2"/>
           <p:cNvSpPr txBox="1"/>
           <p:nvPr/>
         </p:nvSpPr>
@@ -4400,7 +4474,7 @@
       </p:sp>
       <p:sp>
         <p:nvSpPr>
-          <p:cNvPr id="18" name="p2-linia-3"/>
+          <p:cNvPr id="19" name="p2-linia-3"/>
           <p:cNvSpPr/>
           <p:nvPr/>
         </p:nvSpPr>
@@ -4442,7 +4516,7 @@
       </p:sp>
       <p:sp>
         <p:nvSpPr>
-          <p:cNvPr id="19" name="p2-pozycja-3"/>
+          <p:cNvPr id="20" name="p2-pozycja-3"/>
           <p:cNvSpPr txBox="1"/>
           <p:nvPr/>
         </p:nvSpPr>
@@ -4477,7 +4551,7 @@
       </p:sp>
       <p:sp>
         <p:nvSpPr>
-          <p:cNvPr id="20" name="p2-cena-3"/>
+          <p:cNvPr id="21" name="p2-cena-3"/>
           <p:cNvSpPr txBox="1"/>
           <p:nvPr/>
         </p:nvSpPr>
@@ -4512,7 +4586,7 @@
       </p:sp>
       <p:sp>
         <p:nvSpPr>
-          <p:cNvPr id="21" name="p2-zastrzezenie"/>
+          <p:cNvPr id="22" name="p2-zastrzezenie"/>
           <p:cNvSpPr txBox="1"/>
           <p:nvPr/>
         </p:nvSpPr>
@@ -4567,7 +4641,7 @@
       </p:sp>
       <p:sp>
         <p:nvSpPr>
-          <p:cNvPr id="22" name="stopka-linia-1"/>
+          <p:cNvPr id="23" name="stopka-linia-1"/>
           <p:cNvSpPr txBox="1"/>
           <p:nvPr/>
         </p:nvSpPr>
@@ -4602,7 +4676,7 @@
       </p:sp>
       <p:sp>
         <p:nvSpPr>
-          <p:cNvPr id="23" name="stopka-linia-2"/>
+          <p:cNvPr id="24" name="stopka-linia-2"/>
           <p:cNvSpPr txBox="1"/>
           <p:nvPr/>
         </p:nvSpPr>
@@ -4739,17 +4813,429 @@
       </p:sp>
       <p:sp>
         <p:nvSpPr>
-          <p:cNvPr id="4" name="PLACEHOLDER-logo-wstaw-swoje"/>
+          <p:cNvPr id="4" name="RAMKA-ZDJECIE-GOSI-wrzuc-foto"/>
           <p:cNvSpPr/>
           <p:nvPr/>
         </p:nvSpPr>
         <p:spPr>
           <a:xfrm>
-            <a:off x="685800" y="609600"/>
-            <a:ext cx="1104900" cy="1104900"/>
+            <a:off x="685800" y="533400"/>
+            <a:ext cx="1371600" cy="1371600"/>
           </a:xfrm>
           <a:prstGeom prst="ellipse">
             <a:avLst/>
+          </a:prstGeom>
+          <a:solidFill>
+            <a:srgbClr val="3A3631"/>
+          </a:solidFill>
+          <a:ln w="50800">
+            <a:solidFill>
+              <a:srgbClr val="F58220"/>
+            </a:solidFill>
+          </a:ln>
+          <a:effectLst/>
+        </p:spPr>
+        <p:style>
+          <a:lnRef idx="1">
+            <a:schemeClr val="accent1"/>
+          </a:lnRef>
+          <a:fillRef idx="3">
+            <a:schemeClr val="accent1"/>
+          </a:fillRef>
+          <a:effectRef idx="2">
+            <a:schemeClr val="accent1"/>
+          </a:effectRef>
+          <a:fontRef idx="minor">
+            <a:schemeClr val="lt1"/>
+          </a:fontRef>
+        </p:style>
+        <p:txBody>
+          <a:bodyPr rtlCol="0" anchor="ctr"/>
+          <a:lstStyle/>
+          <a:p/>
+        </p:txBody>
+      </p:sp>
+      <p:sp>
+        <p:nvSpPr>
+          <p:cNvPr id="5" name="ramka-podpowiedz-usun"/>
+          <p:cNvSpPr txBox="1"/>
+          <p:nvPr/>
+        </p:nvSpPr>
+        <p:spPr>
+          <a:xfrm>
+            <a:off x="914400" y="1066800"/>
+            <a:ext cx="914400" cy="323850"/>
+          </a:xfrm>
+          <a:prstGeom prst="rect">
+            <a:avLst/>
+          </a:prstGeom>
+          <a:noFill/>
+        </p:spPr>
+        <p:txBody>
+          <a:bodyPr wrap="square" lIns="0" rIns="0" tIns="0" bIns="0" anchor="ctr">
+            <a:spAutoFit/>
+          </a:bodyPr>
+          <a:lstStyle/>
+          <a:p>
+            <a:pPr algn="ctr"/>
+            <a:r>
+              <a:rPr sz="1500" b="0" spc="300">
+                <a:solidFill>
+                  <a:srgbClr val="B8B2AA"/>
+                </a:solidFill>
+                <a:latin typeface="Open Sans"/>
+              </a:rPr>
+              <a:t>FOTO</a:t>
+            </a:r>
+          </a:p>
+        </p:txBody>
+      </p:sp>
+      <p:sp>
+        <p:nvSpPr>
+          <p:cNvPr id="6" name="kicker-imie"/>
+          <p:cNvSpPr txBox="1"/>
+          <p:nvPr/>
+        </p:nvSpPr>
+        <p:spPr>
+          <a:xfrm>
+            <a:off x="2324100" y="704850"/>
+            <a:ext cx="6667500" cy="342900"/>
+          </a:xfrm>
+          <a:prstGeom prst="rect">
+            <a:avLst/>
+          </a:prstGeom>
+          <a:noFill/>
+        </p:spPr>
+        <p:txBody>
+          <a:bodyPr wrap="square" lIns="0" rIns="0" tIns="0" bIns="0" anchor="ctr">
+            <a:spAutoFit/>
+          </a:bodyPr>
+          <a:lstStyle/>
+          <a:p>
+            <a:pPr algn="l"/>
+            <a:r>
+              <a:rPr sz="2025" b="1" spc="500">
+                <a:solidFill>
+                  <a:srgbClr val="F58220"/>
+                </a:solidFill>
+                <a:latin typeface="Montserrat"/>
+              </a:rPr>
+              <a:t>GOSIA</a:t>
+            </a:r>
+          </a:p>
+        </p:txBody>
+      </p:sp>
+      <p:sp>
+        <p:nvSpPr>
+          <p:cNvPr id="7" name="kicker-marka"/>
+          <p:cNvSpPr txBox="1"/>
+          <p:nvPr/>
+        </p:nvSpPr>
+        <p:spPr>
+          <a:xfrm>
+            <a:off x="2324100" y="1066800"/>
+            <a:ext cx="6667500" cy="304800"/>
+          </a:xfrm>
+          <a:prstGeom prst="rect">
+            <a:avLst/>
+          </a:prstGeom>
+          <a:noFill/>
+        </p:spPr>
+        <p:txBody>
+          <a:bodyPr wrap="square" lIns="0" rIns="0" tIns="0" bIns="0" anchor="ctr">
+            <a:spAutoFit/>
+          </a:bodyPr>
+          <a:lstStyle/>
+          <a:p>
+            <a:pPr algn="l"/>
+            <a:r>
+              <a:rPr sz="1725" b="1" spc="400">
+                <a:solidFill>
+                  <a:srgbClr val="FFFFFF"/>
+                </a:solidFill>
+                <a:latin typeface="Montserrat"/>
+              </a:rPr>
+              <a:t>MOUNTAIN CAR GARAGE</a:t>
+            </a:r>
+          </a:p>
+        </p:txBody>
+      </p:sp>
+      <p:sp>
+        <p:nvSpPr>
+          <p:cNvPr id="8" name="kicker-lokalizacja"/>
+          <p:cNvSpPr txBox="1"/>
+          <p:nvPr/>
+        </p:nvSpPr>
+        <p:spPr>
+          <a:xfrm>
+            <a:off x="2324100" y="1390650"/>
+            <a:ext cx="6667500" cy="266700"/>
+          </a:xfrm>
+          <a:prstGeom prst="rect">
+            <a:avLst/>
+          </a:prstGeom>
+          <a:noFill/>
+        </p:spPr>
+        <p:txBody>
+          <a:bodyPr wrap="square" lIns="0" rIns="0" tIns="0" bIns="0" anchor="ctr">
+            <a:spAutoFit/>
+          </a:bodyPr>
+          <a:lstStyle/>
+          <a:p>
+            <a:pPr algn="l"/>
+            <a:r>
+              <a:rPr sz="1425" b="0" spc="300">
+                <a:solidFill>
+                  <a:srgbClr val="D4AF37"/>
+                </a:solidFill>
+                <a:latin typeface="Open Sans"/>
+              </a:rPr>
+              <a:t>NJARÐVÍK · REYKJANESBÆR, ICELAND</a:t>
+            </a:r>
+          </a:p>
+        </p:txBody>
+      </p:sp>
+      <p:sp>
+        <p:nvSpPr>
+          <p:cNvPr id="9" name="pasek-stopka"/>
+          <p:cNvSpPr/>
+          <p:nvPr/>
+        </p:nvSpPr>
+        <p:spPr>
+          <a:xfrm>
+            <a:off x="0" y="11430000"/>
+            <a:ext cx="10287000" cy="1428750"/>
+          </a:xfrm>
+          <a:prstGeom prst="rect">
+            <a:avLst/>
+          </a:prstGeom>
+          <a:solidFill>
+            <a:srgbClr val="F58220"/>
+          </a:solidFill>
+          <a:ln>
+            <a:noFill/>
+          </a:ln>
+          <a:effectLst/>
+        </p:spPr>
+        <p:style>
+          <a:lnRef idx="1">
+            <a:schemeClr val="accent1"/>
+          </a:lnRef>
+          <a:fillRef idx="3">
+            <a:schemeClr val="accent1"/>
+          </a:fillRef>
+          <a:effectRef idx="2">
+            <a:schemeClr val="accent1"/>
+          </a:effectRef>
+          <a:fontRef idx="minor">
+            <a:schemeClr val="lt1"/>
+          </a:fontRef>
+        </p:style>
+        <p:txBody>
+          <a:bodyPr rtlCol="0" anchor="ctr"/>
+          <a:lstStyle/>
+          <a:p/>
+        </p:txBody>
+      </p:sp>
+      <p:sp>
+        <p:nvSpPr>
+          <p:cNvPr id="10" name="p3-naglowek"/>
+          <p:cNvSpPr txBox="1"/>
+          <p:nvPr/>
+        </p:nvSpPr>
+        <p:spPr>
+          <a:xfrm>
+            <a:off x="685800" y="2305050"/>
+            <a:ext cx="8915400" cy="3143250"/>
+          </a:xfrm>
+          <a:prstGeom prst="rect">
+            <a:avLst/>
+          </a:prstGeom>
+          <a:noFill/>
+        </p:spPr>
+        <p:txBody>
+          <a:bodyPr wrap="square" lIns="0" rIns="0" tIns="0" bIns="0" anchor="t">
+            <a:spAutoFit/>
+          </a:bodyPr>
+          <a:lstStyle/>
+          <a:p>
+            <a:pPr algn="l">
+              <a:lnSpc>
+                <a:spcPct val="100000"/>
+              </a:lnSpc>
+            </a:pPr>
+            <a:r>
+              <a:rPr sz="6000" b="1">
+                <a:solidFill>
+                  <a:srgbClr val="FFFFFF"/>
+                </a:solidFill>
+                <a:latin typeface="Montserrat"/>
+              </a:rPr>
+              <a:t>DON'T LEAVE IT</a:t>
+            </a:r>
+          </a:p>
+          <a:p>
+            <a:pPr algn="l">
+              <a:lnSpc>
+                <a:spcPct val="100000"/>
+              </a:lnSpc>
+            </a:pPr>
+            <a:r>
+              <a:rPr sz="6000" b="1">
+                <a:solidFill>
+                  <a:srgbClr val="FFFFFF"/>
+                </a:solidFill>
+                <a:latin typeface="Montserrat"/>
+              </a:rPr>
+              <a:t>TO THE LAST</a:t>
+            </a:r>
+          </a:p>
+          <a:p>
+            <a:pPr algn="l">
+              <a:lnSpc>
+                <a:spcPct val="100000"/>
+              </a:lnSpc>
+            </a:pPr>
+            <a:r>
+              <a:rPr sz="6000" b="1">
+                <a:solidFill>
+                  <a:srgbClr val="F58220"/>
+                </a:solidFill>
+                <a:latin typeface="Montserrat"/>
+              </a:rPr>
+              <a:t>WEEK.</a:t>
+            </a:r>
+          </a:p>
+        </p:txBody>
+      </p:sp>
+      <p:sp>
+        <p:nvSpPr>
+          <p:cNvPr id="11" name="p3-kreska"/>
+          <p:cNvSpPr/>
+          <p:nvPr/>
+        </p:nvSpPr>
+        <p:spPr>
+          <a:xfrm>
+            <a:off x="685800" y="5715000"/>
+            <a:ext cx="1428750" cy="57150"/>
+          </a:xfrm>
+          <a:prstGeom prst="rect">
+            <a:avLst/>
+          </a:prstGeom>
+          <a:solidFill>
+            <a:srgbClr val="D4AF37"/>
+          </a:solidFill>
+          <a:ln>
+            <a:noFill/>
+          </a:ln>
+          <a:effectLst/>
+        </p:spPr>
+        <p:style>
+          <a:lnRef idx="1">
+            <a:schemeClr val="accent1"/>
+          </a:lnRef>
+          <a:fillRef idx="3">
+            <a:schemeClr val="accent1"/>
+          </a:fillRef>
+          <a:effectRef idx="2">
+            <a:schemeClr val="accent1"/>
+          </a:effectRef>
+          <a:fontRef idx="minor">
+            <a:schemeClr val="lt1"/>
+          </a:fontRef>
+        </p:style>
+        <p:txBody>
+          <a:bodyPr rtlCol="0" anchor="ctr"/>
+          <a:lstStyle/>
+          <a:p/>
+        </p:txBody>
+      </p:sp>
+      <p:sp>
+        <p:nvSpPr>
+          <p:cNvPr id="12" name="p3-tresc"/>
+          <p:cNvSpPr txBox="1"/>
+          <p:nvPr/>
+        </p:nvSpPr>
+        <p:spPr>
+          <a:xfrm>
+            <a:off x="685800" y="6096000"/>
+            <a:ext cx="8915400" cy="1809750"/>
+          </a:xfrm>
+          <a:prstGeom prst="rect">
+            <a:avLst/>
+          </a:prstGeom>
+          <a:noFill/>
+        </p:spPr>
+        <p:txBody>
+          <a:bodyPr wrap="square" lIns="0" rIns="0" tIns="0" bIns="0" anchor="t">
+            <a:spAutoFit/>
+          </a:bodyPr>
+          <a:lstStyle/>
+          <a:p>
+            <a:pPr algn="l">
+              <a:lnSpc>
+                <a:spcPct val="135000"/>
+              </a:lnSpc>
+            </a:pPr>
+            <a:r>
+              <a:rPr sz="2400" b="0">
+                <a:solidFill>
+                  <a:srgbClr val="B8B2AA"/>
+                </a:solidFill>
+                <a:latin typeface="Open Sans"/>
+              </a:rPr>
+              <a:t>Failed inspection is rarely the big repair.</a:t>
+            </a:r>
+          </a:p>
+          <a:p>
+            <a:pPr algn="l">
+              <a:lnSpc>
+                <a:spcPct val="135000"/>
+              </a:lnSpc>
+            </a:pPr>
+            <a:r>
+              <a:rPr sz="2400" b="0">
+                <a:solidFill>
+                  <a:srgbClr val="B8B2AA"/>
+                </a:solidFill>
+                <a:latin typeface="Open Sans"/>
+              </a:rPr>
+              <a:t>The part is often not in Iceland — it has to be</a:t>
+            </a:r>
+          </a:p>
+          <a:p>
+            <a:pPr algn="l">
+              <a:lnSpc>
+                <a:spcPct val="135000"/>
+              </a:lnSpc>
+            </a:pPr>
+            <a:r>
+              <a:rPr sz="2400" b="0">
+                <a:solidFill>
+                  <a:srgbClr val="B8B2AA"/>
+                </a:solidFill>
+                <a:latin typeface="Open Sans"/>
+              </a:rPr>
+              <a:t>ordered. Your inspection month does not wait.</a:t>
+            </a:r>
+          </a:p>
+        </p:txBody>
+      </p:sp>
+      <p:sp>
+        <p:nvSpPr>
+          <p:cNvPr id="13" name="karta-kwota-obwodka"/>
+          <p:cNvSpPr/>
+          <p:nvPr/>
+        </p:nvSpPr>
+        <p:spPr>
+          <a:xfrm>
+            <a:off x="685800" y="8305800"/>
+            <a:ext cx="8915400" cy="2057400"/>
+          </a:xfrm>
+          <a:prstGeom prst="roundRect">
+            <a:avLst>
+              <a:gd name="adj" fmla="val 10000"/>
+            </a:avLst>
           </a:prstGeom>
           <a:noFill/>
           <a:ln w="38100">
@@ -4781,161 +5267,14 @@
       </p:sp>
       <p:sp>
         <p:nvSpPr>
-          <p:cNvPr id="5" name="logo-placeholder-napis"/>
+          <p:cNvPr id="14" name="karta-kwota-liczba"/>
           <p:cNvSpPr txBox="1"/>
           <p:nvPr/>
         </p:nvSpPr>
         <p:spPr>
           <a:xfrm>
-            <a:off x="914400" y="990600"/>
-            <a:ext cx="685800" cy="342900"/>
-          </a:xfrm>
-          <a:prstGeom prst="rect">
-            <a:avLst/>
-          </a:prstGeom>
-          <a:noFill/>
-        </p:spPr>
-        <p:txBody>
-          <a:bodyPr wrap="square" lIns="0" rIns="0" tIns="0" bIns="0" anchor="ctr">
-            <a:spAutoFit/>
-          </a:bodyPr>
-          <a:lstStyle/>
-          <a:p>
-            <a:pPr algn="ctr"/>
-            <a:r>
-              <a:rPr sz="1950" b="1" spc="200">
-                <a:solidFill>
-                  <a:srgbClr val="D4AF37"/>
-                </a:solidFill>
-                <a:latin typeface="Montserrat"/>
-              </a:rPr>
-              <a:t>MCG</a:t>
-            </a:r>
-          </a:p>
-        </p:txBody>
-      </p:sp>
-      <p:sp>
-        <p:nvSpPr>
-          <p:cNvPr id="6" name="kicker-marka"/>
-          <p:cNvSpPr txBox="1"/>
-          <p:nvPr/>
-        </p:nvSpPr>
-        <p:spPr>
-          <a:xfrm>
-            <a:off x="2019300" y="819150"/>
-            <a:ext cx="6667500" cy="323850"/>
-          </a:xfrm>
-          <a:prstGeom prst="rect">
-            <a:avLst/>
-          </a:prstGeom>
-          <a:noFill/>
-        </p:spPr>
-        <p:txBody>
-          <a:bodyPr wrap="square" lIns="0" rIns="0" tIns="0" bIns="0" anchor="ctr">
-            <a:spAutoFit/>
-          </a:bodyPr>
-          <a:lstStyle/>
-          <a:p>
-            <a:pPr algn="l"/>
-            <a:r>
-              <a:rPr sz="1875" b="1" spc="450">
-                <a:solidFill>
-                  <a:srgbClr val="FFFFFF"/>
-                </a:solidFill>
-                <a:latin typeface="Montserrat"/>
-              </a:rPr>
-              <a:t>MOUNTAIN CAR GARAGE</a:t>
-            </a:r>
-          </a:p>
-        </p:txBody>
-      </p:sp>
-      <p:sp>
-        <p:nvSpPr>
-          <p:cNvPr id="7" name="kicker-lokalizacja"/>
-          <p:cNvSpPr txBox="1"/>
-          <p:nvPr/>
-        </p:nvSpPr>
-        <p:spPr>
-          <a:xfrm>
-            <a:off x="2019300" y="1181100"/>
-            <a:ext cx="6667500" cy="285750"/>
-          </a:xfrm>
-          <a:prstGeom prst="rect">
-            <a:avLst/>
-          </a:prstGeom>
-          <a:noFill/>
-        </p:spPr>
-        <p:txBody>
-          <a:bodyPr wrap="square" lIns="0" rIns="0" tIns="0" bIns="0" anchor="ctr">
-            <a:spAutoFit/>
-          </a:bodyPr>
-          <a:lstStyle/>
-          <a:p>
-            <a:pPr algn="l"/>
-            <a:r>
-              <a:rPr sz="1575" b="0" spc="300">
-                <a:solidFill>
-                  <a:srgbClr val="D4AF37"/>
-                </a:solidFill>
-                <a:latin typeface="Open Sans"/>
-              </a:rPr>
-              <a:t>NJARÐVÍK · REYKJANESBÆR, ICELAND</a:t>
-            </a:r>
-          </a:p>
-        </p:txBody>
-      </p:sp>
-      <p:sp>
-        <p:nvSpPr>
-          <p:cNvPr id="8" name="pasek-stopka"/>
-          <p:cNvSpPr/>
-          <p:nvPr/>
-        </p:nvSpPr>
-        <p:spPr>
-          <a:xfrm>
-            <a:off x="0" y="11430000"/>
-            <a:ext cx="10287000" cy="1428750"/>
-          </a:xfrm>
-          <a:prstGeom prst="rect">
-            <a:avLst/>
-          </a:prstGeom>
-          <a:solidFill>
-            <a:srgbClr val="F58220"/>
-          </a:solidFill>
-          <a:ln>
-            <a:noFill/>
-          </a:ln>
-          <a:effectLst/>
-        </p:spPr>
-        <p:style>
-          <a:lnRef idx="1">
-            <a:schemeClr val="accent1"/>
-          </a:lnRef>
-          <a:fillRef idx="3">
-            <a:schemeClr val="accent1"/>
-          </a:fillRef>
-          <a:effectRef idx="2">
-            <a:schemeClr val="accent1"/>
-          </a:effectRef>
-          <a:fontRef idx="minor">
-            <a:schemeClr val="lt1"/>
-          </a:fontRef>
-        </p:style>
-        <p:txBody>
-          <a:bodyPr rtlCol="0" anchor="ctr"/>
-          <a:lstStyle/>
-          <a:p/>
-        </p:txBody>
-      </p:sp>
-      <p:sp>
-        <p:nvSpPr>
-          <p:cNvPr id="9" name="p3-naglowek"/>
-          <p:cNvSpPr txBox="1"/>
-          <p:nvPr/>
-        </p:nvSpPr>
-        <p:spPr>
-          <a:xfrm>
-            <a:off x="685800" y="2305050"/>
-            <a:ext cx="8915400" cy="3143250"/>
+            <a:off x="1028700" y="8515350"/>
+            <a:ext cx="6667500" cy="914400"/>
           </a:xfrm>
           <a:prstGeom prst="rect">
             <a:avLst/>
@@ -4948,234 +5287,6 @@
           </a:bodyPr>
           <a:lstStyle/>
           <a:p>
-            <a:pPr algn="l">
-              <a:lnSpc>
-                <a:spcPct val="100000"/>
-              </a:lnSpc>
-            </a:pPr>
-            <a:r>
-              <a:rPr sz="6000" b="1">
-                <a:solidFill>
-                  <a:srgbClr val="FFFFFF"/>
-                </a:solidFill>
-                <a:latin typeface="Montserrat"/>
-              </a:rPr>
-              <a:t>DON'T LEAVE IT</a:t>
-            </a:r>
-          </a:p>
-          <a:p>
-            <a:pPr algn="l">
-              <a:lnSpc>
-                <a:spcPct val="100000"/>
-              </a:lnSpc>
-            </a:pPr>
-            <a:r>
-              <a:rPr sz="6000" b="1">
-                <a:solidFill>
-                  <a:srgbClr val="FFFFFF"/>
-                </a:solidFill>
-                <a:latin typeface="Montserrat"/>
-              </a:rPr>
-              <a:t>TO THE LAST</a:t>
-            </a:r>
-          </a:p>
-          <a:p>
-            <a:pPr algn="l">
-              <a:lnSpc>
-                <a:spcPct val="100000"/>
-              </a:lnSpc>
-            </a:pPr>
-            <a:r>
-              <a:rPr sz="6000" b="1">
-                <a:solidFill>
-                  <a:srgbClr val="F58220"/>
-                </a:solidFill>
-                <a:latin typeface="Montserrat"/>
-              </a:rPr>
-              <a:t>WEEK.</a:t>
-            </a:r>
-          </a:p>
-        </p:txBody>
-      </p:sp>
-      <p:sp>
-        <p:nvSpPr>
-          <p:cNvPr id="10" name="p3-kreska"/>
-          <p:cNvSpPr/>
-          <p:nvPr/>
-        </p:nvSpPr>
-        <p:spPr>
-          <a:xfrm>
-            <a:off x="685800" y="5715000"/>
-            <a:ext cx="1428750" cy="57150"/>
-          </a:xfrm>
-          <a:prstGeom prst="rect">
-            <a:avLst/>
-          </a:prstGeom>
-          <a:solidFill>
-            <a:srgbClr val="D4AF37"/>
-          </a:solidFill>
-          <a:ln>
-            <a:noFill/>
-          </a:ln>
-          <a:effectLst/>
-        </p:spPr>
-        <p:style>
-          <a:lnRef idx="1">
-            <a:schemeClr val="accent1"/>
-          </a:lnRef>
-          <a:fillRef idx="3">
-            <a:schemeClr val="accent1"/>
-          </a:fillRef>
-          <a:effectRef idx="2">
-            <a:schemeClr val="accent1"/>
-          </a:effectRef>
-          <a:fontRef idx="minor">
-            <a:schemeClr val="lt1"/>
-          </a:fontRef>
-        </p:style>
-        <p:txBody>
-          <a:bodyPr rtlCol="0" anchor="ctr"/>
-          <a:lstStyle/>
-          <a:p/>
-        </p:txBody>
-      </p:sp>
-      <p:sp>
-        <p:nvSpPr>
-          <p:cNvPr id="11" name="p3-tresc"/>
-          <p:cNvSpPr txBox="1"/>
-          <p:nvPr/>
-        </p:nvSpPr>
-        <p:spPr>
-          <a:xfrm>
-            <a:off x="685800" y="6096000"/>
-            <a:ext cx="8915400" cy="1809750"/>
-          </a:xfrm>
-          <a:prstGeom prst="rect">
-            <a:avLst/>
-          </a:prstGeom>
-          <a:noFill/>
-        </p:spPr>
-        <p:txBody>
-          <a:bodyPr wrap="square" lIns="0" rIns="0" tIns="0" bIns="0" anchor="t">
-            <a:spAutoFit/>
-          </a:bodyPr>
-          <a:lstStyle/>
-          <a:p>
-            <a:pPr algn="l">
-              <a:lnSpc>
-                <a:spcPct val="135000"/>
-              </a:lnSpc>
-            </a:pPr>
-            <a:r>
-              <a:rPr sz="2400" b="0">
-                <a:solidFill>
-                  <a:srgbClr val="B8B2AA"/>
-                </a:solidFill>
-                <a:latin typeface="Open Sans"/>
-              </a:rPr>
-              <a:t>Failed inspection is rarely the big repair.</a:t>
-            </a:r>
-          </a:p>
-          <a:p>
-            <a:pPr algn="l">
-              <a:lnSpc>
-                <a:spcPct val="135000"/>
-              </a:lnSpc>
-            </a:pPr>
-            <a:r>
-              <a:rPr sz="2400" b="0">
-                <a:solidFill>
-                  <a:srgbClr val="B8B2AA"/>
-                </a:solidFill>
-                <a:latin typeface="Open Sans"/>
-              </a:rPr>
-              <a:t>The part is often not in Iceland — it has to be</a:t>
-            </a:r>
-          </a:p>
-          <a:p>
-            <a:pPr algn="l">
-              <a:lnSpc>
-                <a:spcPct val="135000"/>
-              </a:lnSpc>
-            </a:pPr>
-            <a:r>
-              <a:rPr sz="2400" b="0">
-                <a:solidFill>
-                  <a:srgbClr val="B8B2AA"/>
-                </a:solidFill>
-                <a:latin typeface="Open Sans"/>
-              </a:rPr>
-              <a:t>ordered. Your inspection month does not wait.</a:t>
-            </a:r>
-          </a:p>
-        </p:txBody>
-      </p:sp>
-      <p:sp>
-        <p:nvSpPr>
-          <p:cNvPr id="12" name="karta-kwota-obwodka"/>
-          <p:cNvSpPr/>
-          <p:nvPr/>
-        </p:nvSpPr>
-        <p:spPr>
-          <a:xfrm>
-            <a:off x="685800" y="8305800"/>
-            <a:ext cx="8915400" cy="2057400"/>
-          </a:xfrm>
-          <a:prstGeom prst="roundRect">
-            <a:avLst>
-              <a:gd name="adj" fmla="val 10000"/>
-            </a:avLst>
-          </a:prstGeom>
-          <a:noFill/>
-          <a:ln w="38100">
-            <a:solidFill>
-              <a:srgbClr val="D4AF37"/>
-            </a:solidFill>
-          </a:ln>
-          <a:effectLst/>
-        </p:spPr>
-        <p:style>
-          <a:lnRef idx="1">
-            <a:schemeClr val="accent1"/>
-          </a:lnRef>
-          <a:fillRef idx="3">
-            <a:schemeClr val="accent1"/>
-          </a:fillRef>
-          <a:effectRef idx="2">
-            <a:schemeClr val="accent1"/>
-          </a:effectRef>
-          <a:fontRef idx="minor">
-            <a:schemeClr val="lt1"/>
-          </a:fontRef>
-        </p:style>
-        <p:txBody>
-          <a:bodyPr rtlCol="0" anchor="ctr"/>
-          <a:lstStyle/>
-          <a:p/>
-        </p:txBody>
-      </p:sp>
-      <p:sp>
-        <p:nvSpPr>
-          <p:cNvPr id="13" name="karta-kwota-liczba"/>
-          <p:cNvSpPr txBox="1"/>
-          <p:nvPr/>
-        </p:nvSpPr>
-        <p:spPr>
-          <a:xfrm>
-            <a:off x="1028700" y="8515350"/>
-            <a:ext cx="6667500" cy="914400"/>
-          </a:xfrm>
-          <a:prstGeom prst="rect">
-            <a:avLst/>
-          </a:prstGeom>
-          <a:noFill/>
-        </p:spPr>
-        <p:txBody>
-          <a:bodyPr wrap="square" lIns="0" rIns="0" tIns="0" bIns="0" anchor="t">
-            <a:spAutoFit/>
-          </a:bodyPr>
-          <a:lstStyle/>
-          <a:p>
             <a:pPr algn="l"/>
             <a:r>
               <a:rPr sz="6600" b="1">
@@ -5191,7 +5302,7 @@
       </p:sp>
       <p:sp>
         <p:nvSpPr>
-          <p:cNvPr id="14" name="karta-kwota-opis"/>
+          <p:cNvPr id="15" name="karta-kwota-opis"/>
           <p:cNvSpPr txBox="1"/>
           <p:nvPr/>
         </p:nvSpPr>
@@ -5246,7 +5357,7 @@
       </p:sp>
       <p:sp>
         <p:nvSpPr>
-          <p:cNvPr id="15" name="stopka-linia-1"/>
+          <p:cNvPr id="16" name="stopka-linia-1"/>
           <p:cNvSpPr txBox="1"/>
           <p:nvPr/>
         </p:nvSpPr>
@@ -5281,7 +5392,7 @@
       </p:sp>
       <p:sp>
         <p:nvSpPr>
-          <p:cNvPr id="16" name="stopka-linia-2"/>
+          <p:cNvPr id="17" name="stopka-linia-2"/>
           <p:cNvSpPr txBox="1"/>
           <p:nvPr/>
         </p:nvSpPr>

</xml_diff>